<commit_message>
fix(audio): 补 p14:media 关联，修复 PowerPoint 打不开（ADR-027 续三）
真机反馈：poster 版本 WPS 能开、PowerPoint 打不开。

根因：a:blip 指向 poster 图片时，p:nvPr 缺 p14:media（Microsoft 2007
media 关系）——poster 与媒体的关联。对照：
- video.fixed(blip→视频, 无 p14:media) → PowerPoint OK
- 原生(ref, blip→图片, 有 p14:media) → PowerPoint OK
- 本库(blip→图片, 无 p14:media) → PowerPoint 拒开
规律：blip→媒体文件不需 p14:media；blip→图片则需要。

修复：
- 新增常量 nsPowerPoint2010 / relMedia2007 / mediaExtURI
- AddAudio 补 media 关系（2007/relationships/media → wav）
- buildAudioPicFragment 在 nvPr 内补 p:extLst/p:ext/p14:media
- clone.go classifyCloneRel 归类 relMedia2007（否则克隆含音频页报错）
- 守门扩展 p14:media + ext uri 断言

验证：SDK 回读 kind=audio/profile 正常，Validate 0 错误；
go test ./... + -tags=corpus + validate 37/0 全绿
</commit_message>
<xml_diff>
--- a/testdata/corpus/s004-audio/s004-audio.edited.pptx
+++ b/testdata/corpus/s004-audio/s004-audio.edited.pptx
@@ -101,10 +101,15 @@
           </p:cNvPicPr>
           <p:nvPr>
             <a:audioFile r:link="rId2"/>
+            <p:extLst>
+              <p:ext uri="{DAA4B4D4-6D71-4841-9C94-3DE7FCFB9230}">
+                <p14:media xmlns:p14="http://schemas.microsoft.com/office/powerpoint/2010/main" r:embed="rId3"/>
+              </p:ext>
+            </p:extLst>
           </p:nvPr>
         </p:nvPicPr>
         <p:blipFill>
-          <a:blip r:embed="rId3"/>
+          <a:blip r:embed="rId4"/>
           <a:stretch>
             <a:fillRect/>
           </a:stretch>

</xml_diff>